<commit_message>
Ladeklar 1.0: abgabebereit – Unit/API 132/132, E2E 37/37, alle Dokumente neu erzeugt
- Handbuch-PDFs jetzt mit allen Bildschirmfotos (Rendering aus Datei, Abbruch bei fehlendem Bild)
- Bildschirmfotos neu, inkl. aller 8 Sprachen und Fahrer-Tablet
- Rechtstexte, Businessplan, Marktanalyse, Werbetexte (PDF/DOCX), Pitch-Deck (PPTX/PDF),
  Flyer, Postkarte, Social-Bilder, Testbericht und Plan neu gebaut
- Website und Online-Demo neu gebaut
- Testserver mit höherem Login-Limit (der echte Server bleibt bei 20 je Minute)

Co-Authored-By: Claude Opus 5.5 <noreply@anthropic.com>
Claude-Session: https://claude.ai/code/session_01EZAJU4yFY1ubUt7FTVW4st
</commit_message>
<xml_diff>
--- a/ladeklar/business/Ladeklar_Pitch.pptx
+++ b/ladeklar/business/Ladeklar_Pitch.pptx
@@ -1085,7 +1085,7 @@
           <a:lstStyle/>
           <a:p>
             <a:r>
-              <a:t>Unser Modell ist ein Lizenzmodell. Ich bin der Lizenzgeber: Ich betreibe die Plattform, lege Lizenzen an und rechne ab. Jeder Kunde ist Lizenznehmer und arbeitet unter seinem eigenen Namen, Logo und App-Namen. Die Daten gehören dem Kunden; wir sind Auftragsverarbeiter und sehen keine Lieferungen, keine Fahrernamen und keine Lieferscheine – außer der Kunde gibt den Support-Zugriff zeitlich begrenzt frei. Zu mir: [zwei Sätze zu Ausbildung und Erfahrung]. Ich habe Version 1.0 gebaut. Was mir fehlt, ist Vertriebskraft in der Fläche und eine zweite Entwicklerin oder ein zweiter Entwickler. Deshalb stellen wir im Juli 2027 jemanden für Vertrieb und Kundenerfolg ein, im Oktober eine Entwicklungskraft und im Januar 2028 Partnermanagement und mehrsprachigen Support. Ende 2028 sind wir sechs, Ende 2031 dreizehn.</a:t>
+              <a:t>Unser Modell ist ein Lizenzmodell. Ich bin der Lizenzgeber: Ich betreibe die Plattform, lege Lizenzen an und rechne ab. Jeder Kunde ist Lizenznehmer und arbeitet unter seinem eigenen Namen, Logo und App-Namen. Die Daten gehören dem Kunden; wir sind Auftragsverarbeiter und sehen keine Lieferungen, keine Fahrernamen und keine Lieferscheine. Braucht der Kunde Hilfe, erteilt er eine befristete Support-Freigabe, die protokolliert wird. Zu mir: [zwei Sätze zu Ausbildung und Erfahrung]. Ich habe Version 1.0 gebaut. Was mir fehlt, ist Vertriebskraft in der Fläche und eine zweite Entwicklerin oder ein zweiter Entwickler. Deshalb stellen wir im Juli 2027 jemanden für Vertrieb und Kundenerfolg ein, im Oktober eine Entwicklungskraft und im Januar 2028 Partnermanagement und mehrsprachigen Support. Ende 2028 sind wir sechs, Ende 2031 dreizehn.</a:t>
             </a:r>
           </a:p>
         </p:txBody>
@@ -1225,7 +1225,7 @@
           <a:lstStyle/>
           <a:p>
             <a:r>
-              <a:t>Danke für Ihre Zeit. Wenn Sie es selbst ausprobieren möchten: Der QR-Code öffnet die Online-Demo. Nehmen Sie Ihr Handy als Fahrer und den Laptop als Disposition, und tippen Sie eine Tour durch. Sie werden merken: Ein Tipp, und alles ist klar. Ich freue mich auf Ihre Fragen.</a:t>
+              <a:t>Danke für Ihre Zeit. Wenn Sie es selbst ausprobieren möchten: Der QR-Code öffnet die Online-Demo. Auf dem Laptop zeigt die geteilte Ansicht Büro und Fahrer-Handy nebeneinander – tippen Sie eine Tour durch. Sie werden merken: Ein Tipp, und alles ist klar. Ich freue mich auf Ihre Fragen.</a:t>
             </a:r>
           </a:p>
         </p:txBody>
@@ -1365,7 +1365,7 @@
           <a:lstStyle/>
           <a:p>
             <a:r>
-              <a:t>Ladeklar ersetzt die Anrufe durch Knöpfe. Der Fahrer sieht auf seinem Handy immer genau einen großen Knopf: Bestätigen, Aufgeladen, Abgeladen, Lieferschein fotografieren. Jeder Tipp landet sofort als Push-Mitteilung in der Disposition, mit Uhrzeit. Bevor eine Tour abgeschlossen werden kann, braucht es ein Foto vom Lieferschein. Damit geht der Abliefernachweis noch am selben Tag an den Kunden und an die Buchhaltung. Wenn der Fahrer an der Rampe ankommt, tippt er „Angekommen“ – so entsteht ein Beleg für die Wartezeit, und Standgeld wird durchsetzbar. Die App läuft in acht Sprachen und funktioniert auch im Funkloch. Und ganz wichtig für Betriebsräte: Ladeklar ortet nicht dauerhaft. Ein Standort wird nur im Moment eines Statuswechsels gespeichert, und nur, wenn der Betrieb das einschaltet.</a:t>
+              <a:t>Ladeklar ersetzt die Anrufe durch Knöpfe. Der Fahrer sieht auf seinem Handy immer genau einen großen Knopf: Bestätigen, Aufgeladen, Abgeladen, Lieferschein fotografieren. Jeder Tipp landet sofort als Push-Mitteilung in der Disposition, mit Uhrzeit. Bevor eine Tour abgeschlossen werden kann, braucht es ein Foto vom Lieferschein. Damit geht der Abliefernachweis noch am selben Tag an den Kunden und an die Buchhaltung. Wenn der Fahrer an der Rampe ankommt, tippt er „Angekommen“ – so entsteht ein Beleg für die Wartezeit, und Standgeld wird durchsetzbar. Die App läuft in acht Sprachen und funktioniert auch im Funkloch. Und ganz wichtig für Betriebsräte: Ladeklar ortet nicht dauerhaft. Ein Standort wird nur im Moment eines Statuswechsels gespeichert, und nur, wenn der Betrieb das einschaltet und der Fahrer zustimmt.</a:t>
             </a:r>
           </a:p>
         </p:txBody>
@@ -1435,7 +1435,7 @@
           <a:lstStyle/>
           <a:p>
             <a:r>
-              <a:t>Die Einführung ist der Punkt, an dem die meisten Softwareprojekte in kleinen Betrieben scheitern. Deshalb haben wir sie radikal kurz gemacht. Schritt eins: Der Inhaber lädt sein Logo hoch, trägt seine Lkw und Fahrer ein und schickt jedem Fahrer einen Einladungslink per WhatsApp. Der Fahrer braucht keinen App Store, nur den Link und eine PIN. Schritt zwei: Die Disposition legt eine Lieferung an – Pflicht sind nur Route und Datum. Stammrouten lassen sich mit einem Klick wiederholen. Schritt drei: Der Fahrer tippt, das Büro sieht es. Es gibt keinen Einbautermin, keine Box, keinen Vertrag über 36 Monate. Nach zehn Minuten läuft die erste Tour.</a:t>
+              <a:t>Die Einführung ist der Punkt, an dem die meisten Softwareprojekte in kleinen Betrieben scheitern. Deshalb haben wir sie radikal kurz gemacht. Schritt eins: Der Inhaber lädt sein Logo hoch, trägt seine Lkw und Fahrer ein und schickt jedem Fahrer einen Einladungslink per WhatsApp. Der Fahrer braucht keinen App Store, nur den Link und eine PIN. Schritt zwei: Die Disposition legt eine Lieferung an – Pflicht sind nur Route und Datum. Stammrouten legt sie mit „Wiederholen“ als Kopie neu an. Schritt drei: Der Fahrer tippt, das Büro sieht es. Es gibt keinen Einbautermin, keine Box, keinen Vertrag über 36 Monate. Nach etwa zehn Minuten läuft die erste Tour.</a:t>
             </a:r>
           </a:p>
         </p:txBody>
@@ -1505,13 +1505,13 @@
           <a:lstStyle/>
           <a:p>
             <a:r>
-              <a:t>REGIE: 1. Vorher: Online-Demo auf beiden Geräten geöffnet, Live-Sync zwischen Handy und Laptop aktiv, Beispielfirma „Kaya Transporte“ mit Logo, Fahrer „Ion“ mit Sprache Rumänisch. 2. Auf dem Laptop Lieferung *Stuttgart → Hamburg* anlegen und Ion zuweisen (20 Sekunden). 3. Handy hochhalten: Push kommt an, Ion tippt „Bestätigen“ – Laptop zeigt „Bestätigt, vor 1 Sek.“ 4. „Aufgeladen“, „Abgeladen“, Foto eines mitgebrachten Lieferscheins – Laptop zeigt das Foto. 5. Abliefernachweis als PDF öffnen: Zeitstrahl, Foto, Unterschrift. 6. Zum Schluss Sprache am Handy auf Türkisch umstellen – die Knöpfe bleiben gleich.</a:t>
+              <a:t>REGIE: 1. Vorher: Online-Demo (Artifact-Fassung, als Eigentümer angemeldet) auf beiden Geräten geöffnet, Live-Sync zwischen Handy und Laptop über „Mit zweitem Gerät verbinden“ aktiv, Beispielfirma „Kaya Logistik“ mit Logo, Fahrer „Andrei Popescu“ mit Sprache Rumänisch. 2. Auf dem Laptop Lieferung *Stuttgart → Hamburg* anlegen und Andrei zuweisen (20 Sekunden). 3. Handy hochhalten: Die Mitteilung kommt an, Andrei tippt „Buchung bestätigen“ – der Laptop zeigt die Meldung „gerade eben“. 4. „Angekommen“, „Aufgeladen“, „Angekommen“, „Abgeladen“ (Palettentausch bestätigen), Foto eines mitgebrachten Lieferscheins, auf Wunsch Unterschrift – Laptop zeigt das Foto. 5. Abliefernachweis öffnen: Zeitstempel, Standzeit, Foto, Unterschrift (in der echten App als PDF druckbar). 6. Zum Schluss Sprache am Handy auf Türkisch umstellen – die Knöpfe bleiben gleich.</a:t>
             </a:r>
           </a:p>
           <a:p/>
           <a:p>
             <a:r>
-              <a:t>Ich zeige Ihnen das jetzt live. Links sehen Sie die Disposition, rechts das Handy eines Fahrers, eingestellt auf Rumänisch. Ich lege eine Lieferung an und weise sie Ion zu. Achten Sie auf den Laptop, während Ion tippt. [Demo] Was Sie gerade gesehen haben, ersetzt vier Telefonate und einen Lieferschein, der sonst erst am Freitag im Büro gewesen wäre.</a:t>
+              <a:t>Ich zeige Ihnen das jetzt live. Links sehen Sie die Disposition, rechts das Handy eines Fahrers, eingestellt auf Rumänisch. Ich lege eine Lieferung an und weise sie Andrei zu. Achten Sie auf den Laptop, während Andrei tippt. [Demo] Was Sie gerade gesehen haben, ersetzt vier Telefonate und einen Lieferschein, der sonst erst am Freitag im Büro gewesen wäre.</a:t>
             </a:r>
           </a:p>
         </p:txBody>
@@ -1721,7 +1721,7 @@
           <a:lstStyle/>
           <a:p>
             <a:r>
-              <a:t>Unser größter Wettbewerber ist nicht eine Firma, sondern die Gewohnheit: Telefon, WhatsApp, Zettel und Excel. Das kostet keine Lizenz, aber es erzeugt keine Belege und frisst Zeit. Telematik-Anbieter wie Webfleet oder YellowFox lösen Ortung und Lenkzeiten, brauchen aber meist eine Box im Fahrzeug, kosten je Fahrzeug 15 bis 35 Euro und binden zwei bis drei Jahre. Speditionssoftware wie CarLo oder WinSped ist ein Projekt für den Mittelstand. Am nächsten sind uns App-Tools wie LOGISTIQO oder die Apps von SPEDION und Couplink. Unser Unterschied: Wir sind in zehn Minuten startklar, ohne Hardware, wir erscheinen unter der Marke des Kunden, wir führen Fahrer in acht Sprachen über Icons, und wir orten nicht dauerhaft. Für einen Betrieb mit zehn Fahrern kostet das 129 Euro im Monat. Was wir von den Wettbewerbern lernen, haben wir in die Roadmap übernommen: Mehrstopp-Touren, Saisonpause und Schnittstellen zur vorhandenen Telematik.</a:t>
+              <a:t>Unser größter Wettbewerber ist nicht eine Firma, sondern die Gewohnheit: Telefon, WhatsApp, Zettel und Excel. Das kostet keine Lizenz, aber es erzeugt keine Belege und frisst Zeit. Telematik-Anbieter wie Webfleet oder YellowFox lösen Ortung und Lenkzeiten, brauchen aber meist eine Box im Fahrzeug, kosten je Fahrzeug 15 bis 35 Euro und binden zwei bis drei Jahre. Speditionssoftware wie CarLo oder WinSped ist ein Projekt für den Mittelstand. Am nächsten sind uns App-Tools wie LOGISTIQO oder die Apps von SPEDION und Couplink. Unser Unterschied: Wir sind in etwa zehn Minuten startklar, ohne Hardware, wir erscheinen unter der Marke des Kunden, wir führen Fahrer in acht Sprachen über Icons, und wir orten nicht dauerhaft. Für einen Betrieb mit zehn Fahrern kostet das 129 Euro im Monat. Was wir von den Wettbewerbern lernen, haben wir in die Roadmap übernommen: Mehrstopp-Touren, Saisonpause und Schnittstellen zur vorhandenen Telematik.</a:t>
             </a:r>
           </a:p>
         </p:txBody>
@@ -5143,7 +5143,7 @@
                 </a:solidFill>
                 <a:latin typeface="Manrope"/>
               </a:rPr>
-              <a:t>In 10 Minuten startklar, ohne Hardware, in 8 Sprachen</a:t>
+              <a:t>In etwa 10 Minuten startklar, ohne Hardware, Fahrer-App in 8 Sprachen</a:t>
             </a:r>
           </a:p>
         </p:txBody>
@@ -10400,7 +10400,7 @@
                 </a:solidFill>
                 <a:latin typeface="Manrope"/>
               </a:rPr>
-              <a:t>Standzeit an der Rampe wird gemessen – Beleg für Standgeld</a:t>
+              <a:t>Standzeit an der Rampe wird aus den Ankunfts-Tipps gemessen – Beleg für Standgeld</a:t>
             </a:r>
           </a:p>
           <a:p>
@@ -10974,7 +10974,7 @@
                 </a:solidFill>
                 <a:latin typeface="Archivo ExtraBold"/>
               </a:rPr>
-              <a:t>Einrichten (10 Minuten)</a:t>
+              <a:t>Einrichten (ca. 10 Min.)</a:t>
             </a:r>
           </a:p>
         </p:txBody>
@@ -11382,7 +11382,7 @@
                 </a:solidFill>
                 <a:latin typeface="Archivo ExtraBold"/>
               </a:rPr>
-              <a:t>10 Minuten</a:t>
+              <a:t>ca. 10 Minuten</a:t>
             </a:r>
           </a:p>
         </p:txBody>
@@ -11750,7 +11750,7 @@
                 </a:solidFill>
                 <a:latin typeface="Manrope"/>
               </a:rPr>
-              <a:t>Ablauf: Lieferung anlegen → Bestätigen → Aufgeladen → Abgeladen → Lieferschein-Foto → Abliefernachweis-PDF</a:t>
+              <a:t>Ablauf: Lieferung anlegen → Bestätigen → Angekommen → Aufgeladen → Abgeladen → Lieferschein-Foto → Nachweis</a:t>
             </a:r>
           </a:p>
           <a:p>
@@ -11778,7 +11778,7 @@
                 </a:solidFill>
                 <a:latin typeface="Manrope"/>
               </a:rPr>
-              <a:t>Dauer: 3 Minuten; Ersatz: Bildschirmvideo, falls das WLAN streikt</a:t>
+              <a:t>Dauer: 3 Minuten; Ersatz: geteilte Ansicht oder Video</a:t>
             </a:r>
           </a:p>
         </p:txBody>
@@ -13934,7 +13934,7 @@
                 </a:solidFill>
                 <a:latin typeface="Manrope"/>
               </a:rPr>
-              <a:t>Ladeklar: 10 Minuten, keine Hardware, eigene Marke, 8 Sprachen, keine Dauerortung</a:t>
+              <a:t>Ladeklar: ca. 10 Minuten, keine Hardware, eigene Marke, 8 Sprachen, keine Dauerortung</a:t>
             </a:r>
           </a:p>
         </p:txBody>
@@ -15065,7 +15065,7 @@
                 </a:solidFill>
                 <a:latin typeface="Manrope"/>
               </a:rPr>
-              <a:t>Online-Demo mit Live-Sync zwischen Handy und PC</a:t>
+              <a:t>Online-Demo: Büro und Fahrer-Handy nebeneinander, Live-Sync zwischen Handy und PC (Artifact-Fassung)</a:t>
             </a:r>
           </a:p>
         </p:txBody>

</xml_diff>